<commit_message>
feat(presentation): add "Take it with you" scan-to-explore QR slide to WebAssembly decks
Mirrors the REST decks: left QR -> the WebAssembly site, right QR -> the
Workshops & Tutorials hub. Added to deck.js for all three decks (101, 201-go,
201-rust) and rebuilt the pptx. New per-deck QR assets. wasm-101 uses its local
notes() wrapper to satisfy the slide/notes QA count.
</commit_message>
<xml_diff>
--- a/presentation/wasm-101/wasm-101-r1.1.pptx
+++ b/presentation/wasm-101/wasm-101-r1.1.pptx
@@ -45,9 +45,10 @@
     <p:sldId id="293" r:id="rId39"/>
     <p:sldId id="294" r:id="rId40"/>
     <p:sldId id="295" r:id="rId41"/>
+    <p:sldId id="296" r:id="rId42"/>
   </p:sldIdLst>
   <p:notesMasterIdLst>
-    <p:notesMasterId r:id="rId42"/>
+    <p:notesMasterId r:id="rId43"/>
   </p:notesMasterIdLst>
   <p:sldSz cx="12192000" cy="6858000"/>
   <p:notesSz cx="6858000" cy="12192000"/>
@@ -3557,6 +3558,94 @@
             <a:fld id="{F7021451-1387-4CA6-816F-3879F97B5CBC}" type="slidenum">
               <a:rPr lang="en-US"/>
               <a:t>40</a:t>
+            </a:fld>
+            <a:endParaRPr lang="en-US"/>
+          </a:p>
+        </p:txBody>
+      </p:sp>
+    </p:spTree>
+    <p:extLst>
+      <p:ext uri="{BB962C8B-B14F-4D97-AF65-F5344CB8AC3E}">
+        <p14:creationId xmlns:p14="http://schemas.microsoft.com/office/powerpoint/2010/main" val="1024086991"/>
+      </p:ext>
+    </p:extLst>
+  </p:cSld>
+  <p:clrMapOvr>
+    <a:masterClrMapping/>
+  </p:clrMapOvr>
+</p:notes>
+</file>
+
+<file path=ppt/notesSlides/notesSlide41.xml><?xml version="1.0" encoding="utf-8"?>
+<p:notes xmlns:a="http://schemas.openxmlformats.org/drawingml/2006/main" xmlns:r="http://schemas.openxmlformats.org/officeDocument/2006/relationships" xmlns:p="http://schemas.openxmlformats.org/presentationml/2006/main">
+  <p:cSld>
+    <p:spTree>
+      <p:nvGrpSpPr>
+        <p:cNvPr id="1" name=""/>
+        <p:cNvGrpSpPr/>
+        <p:nvPr/>
+      </p:nvGrpSpPr>
+      <p:grpSpPr>
+        <a:xfrm>
+          <a:off x="0" y="0"/>
+          <a:ext cx="0" cy="0"/>
+          <a:chOff x="0" y="0"/>
+          <a:chExt cx="0" cy="0"/>
+        </a:xfrm>
+      </p:grpSpPr>
+      <p:sp>
+        <p:nvSpPr>
+          <p:cNvPr id="2" name="Slide Image Placeholder 1"/>
+          <p:cNvSpPr>
+            <a:spLocks noGrp="1" noRot="1" noChangeAspect="1"/>
+          </p:cNvSpPr>
+          <p:nvPr>
+            <p:ph type="sldImg"/>
+          </p:nvPr>
+        </p:nvSpPr>
+        <p:spPr/>
+      </p:sp>
+      <p:sp>
+        <p:nvSpPr>
+          <p:cNvPr id="3" name="Notes Placeholder 2"/>
+          <p:cNvSpPr>
+            <a:spLocks noGrp="1"/>
+          </p:cNvSpPr>
+          <p:nvPr>
+            <p:ph type="body" idx="1"/>
+          </p:nvPr>
+        </p:nvSpPr>
+        <p:spPr/>
+        <p:txBody>
+          <a:bodyPr/>
+          <a:lstStyle/>
+          <a:p>
+            <a:r>
+              <a:rPr lang="en-US" dirty="0"/>
+              <a:t>This is the 101 concepts deck, so the two codes point where the ideas live and where the whole series lives. On the left, the site: the chapters, the WIT interfaces, and the runnable Rust and TinyGo examples, all public. On the right, the Workshops and Tutorials hub: every workshop, tutorial, and deck in the series in one place. Scan whichever is useful; both are on the Pattern Catalyst GitHub organization.</a:t>
+            </a:r>
+            <a:endParaRPr lang="en-US" dirty="0"/>
+          </a:p>
+        </p:txBody>
+      </p:sp>
+      <p:sp>
+        <p:nvSpPr>
+          <p:cNvPr id="4" name="Slide Number Placeholder 3"/>
+          <p:cNvSpPr>
+            <a:spLocks noGrp="1"/>
+          </p:cNvSpPr>
+          <p:nvPr>
+            <p:ph type="sldNum" sz="quarter" idx="10"/>
+          </p:nvPr>
+        </p:nvSpPr>
+        <p:spPr/>
+        <p:txBody>
+          <a:bodyPr/>
+          <a:lstStyle/>
+          <a:p>
+            <a:fld id="{F7021451-1387-4CA6-816F-3879F97B5CBC}" type="slidenum">
+              <a:rPr lang="en-US"/>
+              <a:t>41</a:t>
             </a:fld>
             <a:endParaRPr lang="en-US"/>
           </a:p>
@@ -17270,6 +17359,454 @@
 </p:sld>
 </file>
 
+<file path=ppt/slides/slide41.xml><?xml version="1.0" encoding="utf-8"?>
+<p:sld xmlns:a="http://schemas.openxmlformats.org/drawingml/2006/main" xmlns:r="http://schemas.openxmlformats.org/officeDocument/2006/relationships" xmlns:p="http://schemas.openxmlformats.org/presentationml/2006/main">
+  <p:cSld name="Slide 41">
+    <p:spTree>
+      <p:nvGrpSpPr>
+        <p:cNvPr id="1" name=""/>
+        <p:cNvGrpSpPr/>
+        <p:nvPr/>
+      </p:nvGrpSpPr>
+      <p:grpSpPr>
+        <a:xfrm>
+          <a:off x="0" y="0"/>
+          <a:ext cx="0" cy="0"/>
+          <a:chOff x="0" y="0"/>
+          <a:chExt cx="0" cy="0"/>
+        </a:xfrm>
+      </p:grpSpPr>
+      <p:sp>
+        <p:nvSpPr>
+          <p:cNvPr id="2" name="Text 0"/>
+          <p:cNvSpPr/>
+          <p:nvPr/>
+        </p:nvSpPr>
+        <p:spPr>
+          <a:xfrm>
+            <a:off x="566928" y="6364224"/>
+            <a:ext cx="914400" cy="274320"/>
+          </a:xfrm>
+          <a:prstGeom prst="rect">
+            <a:avLst/>
+          </a:prstGeom>
+          <a:noFill/>
+          <a:ln/>
+        </p:spPr>
+        <p:txBody>
+          <a:bodyPr wrap="square" rtlCol="0" anchor="ctr"/>
+          <a:lstStyle/>
+          <a:p>
+            <a:pPr algn="l" indent="0" marL="0">
+              <a:buNone/>
+            </a:pPr>
+            <a:r>
+              <a:rPr lang="en-US" sz="1000" dirty="0">
+                <a:solidFill>
+                  <a:srgbClr val="8A8A8A"/>
+                </a:solidFill>
+                <a:latin typeface="Red Hat Text" pitchFamily="34" charset="0"/>
+                <a:ea typeface="Red Hat Text" pitchFamily="34" charset="-122"/>
+                <a:cs typeface="Red Hat Text" pitchFamily="34" charset="-120"/>
+              </a:rPr>
+              <a:t>41</a:t>
+            </a:r>
+            <a:endParaRPr lang="en-US" sz="1000" dirty="0"/>
+          </a:p>
+        </p:txBody>
+      </p:sp>
+      <p:pic>
+        <p:nvPicPr>
+          <p:cNvPr id="3" name="Image 0" descr="./assets/logo-candidate-2.png">    </p:cNvPr>
+          <p:cNvPicPr>
+            <a:picLocks noChangeAspect="1"/>
+          </p:cNvPicPr>
+          <p:nvPr/>
+        </p:nvPicPr>
+        <p:blipFill>
+          <a:blip r:embed="rId1"/>
+          <a:stretch>
+            <a:fillRect/>
+          </a:stretch>
+        </p:blipFill>
+        <p:spPr>
+          <a:xfrm>
+            <a:off x="10561320" y="6355080"/>
+            <a:ext cx="1033272" cy="246888"/>
+          </a:xfrm>
+          <a:prstGeom prst="rect">
+            <a:avLst/>
+          </a:prstGeom>
+        </p:spPr>
+      </p:pic>
+      <p:sp>
+        <p:nvSpPr>
+          <p:cNvPr id="4" name="Text 1"/>
+          <p:cNvSpPr/>
+          <p:nvPr/>
+        </p:nvSpPr>
+        <p:spPr>
+          <a:xfrm>
+            <a:off x="566928" y="384048"/>
+            <a:ext cx="11055096" cy="292608"/>
+          </a:xfrm>
+          <a:prstGeom prst="rect">
+            <a:avLst/>
+          </a:prstGeom>
+          <a:noFill/>
+          <a:ln/>
+        </p:spPr>
+        <p:txBody>
+          <a:bodyPr wrap="square" rtlCol="0" anchor="ctr"/>
+          <a:lstStyle/>
+          <a:p>
+            <a:pPr algn="l" indent="0" marL="0">
+              <a:buNone/>
+            </a:pPr>
+            <a:r>
+              <a:rPr lang="en-US" sz="1200" b="1" spc="400" kern="0" dirty="0">
+                <a:solidFill>
+                  <a:srgbClr val="EE0000"/>
+                </a:solidFill>
+                <a:latin typeface="Overpass" pitchFamily="34" charset="0"/>
+                <a:ea typeface="Overpass" pitchFamily="34" charset="-122"/>
+                <a:cs typeface="Overpass" pitchFamily="34" charset="-120"/>
+              </a:rPr>
+              <a:t>SCAN TO EXPLORE</a:t>
+            </a:r>
+            <a:endParaRPr lang="en-US" sz="1200" dirty="0"/>
+          </a:p>
+        </p:txBody>
+      </p:sp>
+      <p:sp>
+        <p:nvSpPr>
+          <p:cNvPr id="5" name="Text 2"/>
+          <p:cNvSpPr/>
+          <p:nvPr/>
+        </p:nvSpPr>
+        <p:spPr>
+          <a:xfrm>
+            <a:off x="566928" y="676656"/>
+            <a:ext cx="11055096" cy="1005840"/>
+          </a:xfrm>
+          <a:prstGeom prst="rect">
+            <a:avLst/>
+          </a:prstGeom>
+          <a:noFill/>
+          <a:ln/>
+        </p:spPr>
+        <p:txBody>
+          <a:bodyPr wrap="square" rtlCol="0" anchor="t"/>
+          <a:lstStyle/>
+          <a:p>
+            <a:pPr algn="l" indent="0" marL="0">
+              <a:buNone/>
+            </a:pPr>
+            <a:r>
+              <a:rPr lang="en-US" sz="3000" b="1" dirty="0">
+                <a:solidFill>
+                  <a:srgbClr val="151515"/>
+                </a:solidFill>
+                <a:latin typeface="Overpass" pitchFamily="34" charset="0"/>
+                <a:ea typeface="Overpass" pitchFamily="34" charset="-122"/>
+                <a:cs typeface="Overpass" pitchFamily="34" charset="-120"/>
+              </a:rPr>
+              <a:t>Take it with you</a:t>
+            </a:r>
+            <a:endParaRPr lang="en-US" sz="3000" dirty="0"/>
+          </a:p>
+        </p:txBody>
+      </p:sp>
+      <p:pic>
+        <p:nvPicPr>
+          <p:cNvPr id="6" name="Image 1" descr="./assets/qr-webassembly-site.png">    </p:cNvPr>
+          <p:cNvPicPr>
+            <a:picLocks noChangeAspect="1"/>
+          </p:cNvPicPr>
+          <p:nvPr/>
+        </p:nvPicPr>
+        <p:blipFill>
+          <a:blip r:embed="rId2"/>
+          <a:stretch>
+            <a:fillRect/>
+          </a:stretch>
+        </p:blipFill>
+        <p:spPr>
+          <a:xfrm>
+            <a:off x="2103120" y="1627632"/>
+            <a:ext cx="2834640" cy="2834640"/>
+          </a:xfrm>
+          <a:prstGeom prst="rect">
+            <a:avLst/>
+          </a:prstGeom>
+        </p:spPr>
+      </p:pic>
+      <p:sp>
+        <p:nvSpPr>
+          <p:cNvPr id="7" name="Text 3"/>
+          <p:cNvSpPr/>
+          <p:nvPr/>
+        </p:nvSpPr>
+        <p:spPr>
+          <a:xfrm>
+            <a:off x="1417320" y="4553712"/>
+            <a:ext cx="4206240" cy="365760"/>
+          </a:xfrm>
+          <a:prstGeom prst="rect">
+            <a:avLst/>
+          </a:prstGeom>
+          <a:noFill/>
+          <a:ln/>
+        </p:spPr>
+        <p:txBody>
+          <a:bodyPr wrap="square" rtlCol="0" anchor="ctr"/>
+          <a:lstStyle/>
+          <a:p>
+            <a:pPr algn="ctr" indent="0" marL="0">
+              <a:buNone/>
+            </a:pPr>
+            <a:r>
+              <a:rPr lang="en-US" sz="1800" b="1" dirty="0">
+                <a:solidFill>
+                  <a:srgbClr val="151515"/>
+                </a:solidFill>
+                <a:latin typeface="Overpass" pitchFamily="34" charset="0"/>
+                <a:ea typeface="Overpass" pitchFamily="34" charset="-122"/>
+                <a:cs typeface="Overpass" pitchFamily="34" charset="-120"/>
+              </a:rPr>
+              <a:t>The site</a:t>
+            </a:r>
+            <a:endParaRPr lang="en-US" sz="1800" dirty="0"/>
+          </a:p>
+        </p:txBody>
+      </p:sp>
+      <p:sp>
+        <p:nvSpPr>
+          <p:cNvPr id="8" name="Text 4"/>
+          <p:cNvSpPr/>
+          <p:nvPr/>
+        </p:nvSpPr>
+        <p:spPr>
+          <a:xfrm>
+            <a:off x="1325880" y="4937760"/>
+            <a:ext cx="4389120" cy="658368"/>
+          </a:xfrm>
+          <a:prstGeom prst="rect">
+            <a:avLst/>
+          </a:prstGeom>
+          <a:noFill/>
+          <a:ln/>
+        </p:spPr>
+        <p:txBody>
+          <a:bodyPr wrap="square" rtlCol="0" anchor="t"/>
+          <a:lstStyle/>
+          <a:p>
+            <a:pPr algn="ctr" indent="0" marL="0">
+              <a:buNone/>
+            </a:pPr>
+            <a:r>
+              <a:rPr lang="en-US" sz="1300" i="1" dirty="0">
+                <a:solidFill>
+                  <a:srgbClr val="5A5A5A"/>
+                </a:solidFill>
+                <a:latin typeface="Red Hat Text" pitchFamily="34" charset="0"/>
+                <a:ea typeface="Red Hat Text" pitchFamily="34" charset="-122"/>
+                <a:cs typeface="Red Hat Text" pitchFamily="34" charset="-120"/>
+              </a:rPr>
+              <a:t>Chapters, the WIT interfaces, and runnable Rust &amp; TinyGo examples</a:t>
+            </a:r>
+            <a:endParaRPr lang="en-US" sz="1300" dirty="0"/>
+          </a:p>
+        </p:txBody>
+      </p:sp>
+      <p:sp>
+        <p:nvSpPr>
+          <p:cNvPr id="9" name="Text 5"/>
+          <p:cNvSpPr/>
+          <p:nvPr/>
+        </p:nvSpPr>
+        <p:spPr>
+          <a:xfrm>
+            <a:off x="1325880" y="5596128"/>
+            <a:ext cx="4389120" cy="292608"/>
+          </a:xfrm>
+          <a:prstGeom prst="rect">
+            <a:avLst/>
+          </a:prstGeom>
+          <a:noFill/>
+          <a:ln/>
+        </p:spPr>
+        <p:txBody>
+          <a:bodyPr wrap="square" rtlCol="0" anchor="ctr"/>
+          <a:lstStyle/>
+          <a:p>
+            <a:pPr algn="ctr" indent="0" marL="0">
+              <a:buNone/>
+            </a:pPr>
+            <a:r>
+              <a:rPr lang="en-US" sz="1000" dirty="0">
+                <a:solidFill>
+                  <a:srgbClr val="EE0000"/>
+                </a:solidFill>
+                <a:latin typeface="Red Hat Mono" pitchFamily="34" charset="0"/>
+                <a:ea typeface="Red Hat Mono" pitchFamily="34" charset="-122"/>
+                <a:cs typeface="Red Hat Mono" pitchFamily="34" charset="-120"/>
+              </a:rPr>
+              <a:t>patterncatalyst.github.io/cn-patterns-and-practices-webassembly</a:t>
+            </a:r>
+            <a:endParaRPr lang="en-US" sz="1000" dirty="0"/>
+          </a:p>
+        </p:txBody>
+      </p:sp>
+      <p:pic>
+        <p:nvPicPr>
+          <p:cNvPr id="10" name="Image 2" descr="./assets/qr-hub.png">    </p:cNvPr>
+          <p:cNvPicPr>
+            <a:picLocks noChangeAspect="1"/>
+          </p:cNvPicPr>
+          <p:nvPr/>
+        </p:nvPicPr>
+        <p:blipFill>
+          <a:blip r:embed="rId3"/>
+          <a:stretch>
+            <a:fillRect/>
+          </a:stretch>
+        </p:blipFill>
+        <p:spPr>
+          <a:xfrm>
+            <a:off x="7251192" y="1627632"/>
+            <a:ext cx="2834640" cy="2834640"/>
+          </a:xfrm>
+          <a:prstGeom prst="rect">
+            <a:avLst/>
+          </a:prstGeom>
+        </p:spPr>
+      </p:pic>
+      <p:sp>
+        <p:nvSpPr>
+          <p:cNvPr id="11" name="Text 6"/>
+          <p:cNvSpPr/>
+          <p:nvPr/>
+        </p:nvSpPr>
+        <p:spPr>
+          <a:xfrm>
+            <a:off x="6565392" y="4553712"/>
+            <a:ext cx="4206240" cy="365760"/>
+          </a:xfrm>
+          <a:prstGeom prst="rect">
+            <a:avLst/>
+          </a:prstGeom>
+          <a:noFill/>
+          <a:ln/>
+        </p:spPr>
+        <p:txBody>
+          <a:bodyPr wrap="square" rtlCol="0" anchor="ctr"/>
+          <a:lstStyle/>
+          <a:p>
+            <a:pPr algn="ctr" indent="0" marL="0">
+              <a:buNone/>
+            </a:pPr>
+            <a:r>
+              <a:rPr lang="en-US" sz="1800" b="1" dirty="0">
+                <a:solidFill>
+                  <a:srgbClr val="151515"/>
+                </a:solidFill>
+                <a:latin typeface="Overpass" pitchFamily="34" charset="0"/>
+                <a:ea typeface="Overpass" pitchFamily="34" charset="-122"/>
+                <a:cs typeface="Overpass" pitchFamily="34" charset="-120"/>
+              </a:rPr>
+              <a:t>Workshops &amp; Tutorials</a:t>
+            </a:r>
+            <a:endParaRPr lang="en-US" sz="1800" dirty="0"/>
+          </a:p>
+        </p:txBody>
+      </p:sp>
+      <p:sp>
+        <p:nvSpPr>
+          <p:cNvPr id="12" name="Text 7"/>
+          <p:cNvSpPr/>
+          <p:nvPr/>
+        </p:nvSpPr>
+        <p:spPr>
+          <a:xfrm>
+            <a:off x="6473952" y="4937760"/>
+            <a:ext cx="4389120" cy="658368"/>
+          </a:xfrm>
+          <a:prstGeom prst="rect">
+            <a:avLst/>
+          </a:prstGeom>
+          <a:noFill/>
+          <a:ln/>
+        </p:spPr>
+        <p:txBody>
+          <a:bodyPr wrap="square" rtlCol="0" anchor="t"/>
+          <a:lstStyle/>
+          <a:p>
+            <a:pPr algn="ctr" indent="0" marL="0">
+              <a:buNone/>
+            </a:pPr>
+            <a:r>
+              <a:rPr lang="en-US" sz="1300" i="1" dirty="0">
+                <a:solidFill>
+                  <a:srgbClr val="5A5A5A"/>
+                </a:solidFill>
+                <a:latin typeface="Red Hat Text" pitchFamily="34" charset="0"/>
+                <a:ea typeface="Red Hat Text" pitchFamily="34" charset="-122"/>
+                <a:cs typeface="Red Hat Text" pitchFamily="34" charset="-120"/>
+              </a:rPr>
+              <a:t>The whole series: every workshop, tutorial, and deck in one place</a:t>
+            </a:r>
+            <a:endParaRPr lang="en-US" sz="1300" dirty="0"/>
+          </a:p>
+        </p:txBody>
+      </p:sp>
+      <p:sp>
+        <p:nvSpPr>
+          <p:cNvPr id="13" name="Text 8"/>
+          <p:cNvSpPr/>
+          <p:nvPr/>
+        </p:nvSpPr>
+        <p:spPr>
+          <a:xfrm>
+            <a:off x="6473952" y="5596128"/>
+            <a:ext cx="4389120" cy="292608"/>
+          </a:xfrm>
+          <a:prstGeom prst="rect">
+            <a:avLst/>
+          </a:prstGeom>
+          <a:noFill/>
+          <a:ln/>
+        </p:spPr>
+        <p:txBody>
+          <a:bodyPr wrap="square" rtlCol="0" anchor="ctr"/>
+          <a:lstStyle/>
+          <a:p>
+            <a:pPr algn="ctr" indent="0" marL="0">
+              <a:buNone/>
+            </a:pPr>
+            <a:r>
+              <a:rPr lang="en-US" sz="900" dirty="0">
+                <a:solidFill>
+                  <a:srgbClr val="EE0000"/>
+                </a:solidFill>
+                <a:latin typeface="Red Hat Mono" pitchFamily="34" charset="0"/>
+                <a:ea typeface="Red Hat Mono" pitchFamily="34" charset="-122"/>
+                <a:cs typeface="Red Hat Mono" pitchFamily="34" charset="-120"/>
+              </a:rPr>
+              <a:t>patterncatalyst.github.io/patterncatalyst-workshops-tutorials-list</a:t>
+            </a:r>
+            <a:endParaRPr lang="en-US" sz="900" dirty="0"/>
+          </a:p>
+        </p:txBody>
+      </p:sp>
+    </p:spTree>
+  </p:cSld>
+  <p:clrMapOvr>
+    <a:masterClrMapping/>
+  </p:clrMapOvr>
+</p:sld>
+</file>
+
 <file path=ppt/slides/slide5.xml><?xml version="1.0" encoding="utf-8"?>
 <p:sld xmlns:a="http://schemas.openxmlformats.org/drawingml/2006/main" xmlns:r="http://schemas.openxmlformats.org/officeDocument/2006/relationships" xmlns:p="http://schemas.openxmlformats.org/presentationml/2006/main">
   <p:cSld name="Slide 5">

</xml_diff>

<commit_message>
feat(presentation): add "Take it with you" scan-to-explore QR slide to WebAssembly decks (#24)
Mirrors the REST decks: left QR -> the WebAssembly site, right QR -> the
Workshops & Tutorials hub. Added to deck.js for all three decks (101, 201-go,
201-rust) and rebuilt the pptx. New per-deck QR assets. wasm-101 uses its local
notes() wrapper to satisfy the slide/notes QA count.
</commit_message>
<xml_diff>
--- a/presentation/wasm-101/wasm-101-r1.1.pptx
+++ b/presentation/wasm-101/wasm-101-r1.1.pptx
@@ -45,9 +45,10 @@
     <p:sldId id="293" r:id="rId39"/>
     <p:sldId id="294" r:id="rId40"/>
     <p:sldId id="295" r:id="rId41"/>
+    <p:sldId id="296" r:id="rId42"/>
   </p:sldIdLst>
   <p:notesMasterIdLst>
-    <p:notesMasterId r:id="rId42"/>
+    <p:notesMasterId r:id="rId43"/>
   </p:notesMasterIdLst>
   <p:sldSz cx="12192000" cy="6858000"/>
   <p:notesSz cx="6858000" cy="12192000"/>
@@ -3557,6 +3558,94 @@
             <a:fld id="{F7021451-1387-4CA6-816F-3879F97B5CBC}" type="slidenum">
               <a:rPr lang="en-US"/>
               <a:t>40</a:t>
+            </a:fld>
+            <a:endParaRPr lang="en-US"/>
+          </a:p>
+        </p:txBody>
+      </p:sp>
+    </p:spTree>
+    <p:extLst>
+      <p:ext uri="{BB962C8B-B14F-4D97-AF65-F5344CB8AC3E}">
+        <p14:creationId xmlns:p14="http://schemas.microsoft.com/office/powerpoint/2010/main" val="1024086991"/>
+      </p:ext>
+    </p:extLst>
+  </p:cSld>
+  <p:clrMapOvr>
+    <a:masterClrMapping/>
+  </p:clrMapOvr>
+</p:notes>
+</file>
+
+<file path=ppt/notesSlides/notesSlide41.xml><?xml version="1.0" encoding="utf-8"?>
+<p:notes xmlns:a="http://schemas.openxmlformats.org/drawingml/2006/main" xmlns:r="http://schemas.openxmlformats.org/officeDocument/2006/relationships" xmlns:p="http://schemas.openxmlformats.org/presentationml/2006/main">
+  <p:cSld>
+    <p:spTree>
+      <p:nvGrpSpPr>
+        <p:cNvPr id="1" name=""/>
+        <p:cNvGrpSpPr/>
+        <p:nvPr/>
+      </p:nvGrpSpPr>
+      <p:grpSpPr>
+        <a:xfrm>
+          <a:off x="0" y="0"/>
+          <a:ext cx="0" cy="0"/>
+          <a:chOff x="0" y="0"/>
+          <a:chExt cx="0" cy="0"/>
+        </a:xfrm>
+      </p:grpSpPr>
+      <p:sp>
+        <p:nvSpPr>
+          <p:cNvPr id="2" name="Slide Image Placeholder 1"/>
+          <p:cNvSpPr>
+            <a:spLocks noGrp="1" noRot="1" noChangeAspect="1"/>
+          </p:cNvSpPr>
+          <p:nvPr>
+            <p:ph type="sldImg"/>
+          </p:nvPr>
+        </p:nvSpPr>
+        <p:spPr/>
+      </p:sp>
+      <p:sp>
+        <p:nvSpPr>
+          <p:cNvPr id="3" name="Notes Placeholder 2"/>
+          <p:cNvSpPr>
+            <a:spLocks noGrp="1"/>
+          </p:cNvSpPr>
+          <p:nvPr>
+            <p:ph type="body" idx="1"/>
+          </p:nvPr>
+        </p:nvSpPr>
+        <p:spPr/>
+        <p:txBody>
+          <a:bodyPr/>
+          <a:lstStyle/>
+          <a:p>
+            <a:r>
+              <a:rPr lang="en-US" dirty="0"/>
+              <a:t>This is the 101 concepts deck, so the two codes point where the ideas live and where the whole series lives. On the left, the site: the chapters, the WIT interfaces, and the runnable Rust and TinyGo examples, all public. On the right, the Workshops and Tutorials hub: every workshop, tutorial, and deck in the series in one place. Scan whichever is useful; both are on the Pattern Catalyst GitHub organization.</a:t>
+            </a:r>
+            <a:endParaRPr lang="en-US" dirty="0"/>
+          </a:p>
+        </p:txBody>
+      </p:sp>
+      <p:sp>
+        <p:nvSpPr>
+          <p:cNvPr id="4" name="Slide Number Placeholder 3"/>
+          <p:cNvSpPr>
+            <a:spLocks noGrp="1"/>
+          </p:cNvSpPr>
+          <p:nvPr>
+            <p:ph type="sldNum" sz="quarter" idx="10"/>
+          </p:nvPr>
+        </p:nvSpPr>
+        <p:spPr/>
+        <p:txBody>
+          <a:bodyPr/>
+          <a:lstStyle/>
+          <a:p>
+            <a:fld id="{F7021451-1387-4CA6-816F-3879F97B5CBC}" type="slidenum">
+              <a:rPr lang="en-US"/>
+              <a:t>41</a:t>
             </a:fld>
             <a:endParaRPr lang="en-US"/>
           </a:p>
@@ -17270,6 +17359,454 @@
 </p:sld>
 </file>
 
+<file path=ppt/slides/slide41.xml><?xml version="1.0" encoding="utf-8"?>
+<p:sld xmlns:a="http://schemas.openxmlformats.org/drawingml/2006/main" xmlns:r="http://schemas.openxmlformats.org/officeDocument/2006/relationships" xmlns:p="http://schemas.openxmlformats.org/presentationml/2006/main">
+  <p:cSld name="Slide 41">
+    <p:spTree>
+      <p:nvGrpSpPr>
+        <p:cNvPr id="1" name=""/>
+        <p:cNvGrpSpPr/>
+        <p:nvPr/>
+      </p:nvGrpSpPr>
+      <p:grpSpPr>
+        <a:xfrm>
+          <a:off x="0" y="0"/>
+          <a:ext cx="0" cy="0"/>
+          <a:chOff x="0" y="0"/>
+          <a:chExt cx="0" cy="0"/>
+        </a:xfrm>
+      </p:grpSpPr>
+      <p:sp>
+        <p:nvSpPr>
+          <p:cNvPr id="2" name="Text 0"/>
+          <p:cNvSpPr/>
+          <p:nvPr/>
+        </p:nvSpPr>
+        <p:spPr>
+          <a:xfrm>
+            <a:off x="566928" y="6364224"/>
+            <a:ext cx="914400" cy="274320"/>
+          </a:xfrm>
+          <a:prstGeom prst="rect">
+            <a:avLst/>
+          </a:prstGeom>
+          <a:noFill/>
+          <a:ln/>
+        </p:spPr>
+        <p:txBody>
+          <a:bodyPr wrap="square" rtlCol="0" anchor="ctr"/>
+          <a:lstStyle/>
+          <a:p>
+            <a:pPr algn="l" indent="0" marL="0">
+              <a:buNone/>
+            </a:pPr>
+            <a:r>
+              <a:rPr lang="en-US" sz="1000" dirty="0">
+                <a:solidFill>
+                  <a:srgbClr val="8A8A8A"/>
+                </a:solidFill>
+                <a:latin typeface="Red Hat Text" pitchFamily="34" charset="0"/>
+                <a:ea typeface="Red Hat Text" pitchFamily="34" charset="-122"/>
+                <a:cs typeface="Red Hat Text" pitchFamily="34" charset="-120"/>
+              </a:rPr>
+              <a:t>41</a:t>
+            </a:r>
+            <a:endParaRPr lang="en-US" sz="1000" dirty="0"/>
+          </a:p>
+        </p:txBody>
+      </p:sp>
+      <p:pic>
+        <p:nvPicPr>
+          <p:cNvPr id="3" name="Image 0" descr="./assets/logo-candidate-2.png">    </p:cNvPr>
+          <p:cNvPicPr>
+            <a:picLocks noChangeAspect="1"/>
+          </p:cNvPicPr>
+          <p:nvPr/>
+        </p:nvPicPr>
+        <p:blipFill>
+          <a:blip r:embed="rId1"/>
+          <a:stretch>
+            <a:fillRect/>
+          </a:stretch>
+        </p:blipFill>
+        <p:spPr>
+          <a:xfrm>
+            <a:off x="10561320" y="6355080"/>
+            <a:ext cx="1033272" cy="246888"/>
+          </a:xfrm>
+          <a:prstGeom prst="rect">
+            <a:avLst/>
+          </a:prstGeom>
+        </p:spPr>
+      </p:pic>
+      <p:sp>
+        <p:nvSpPr>
+          <p:cNvPr id="4" name="Text 1"/>
+          <p:cNvSpPr/>
+          <p:nvPr/>
+        </p:nvSpPr>
+        <p:spPr>
+          <a:xfrm>
+            <a:off x="566928" y="384048"/>
+            <a:ext cx="11055096" cy="292608"/>
+          </a:xfrm>
+          <a:prstGeom prst="rect">
+            <a:avLst/>
+          </a:prstGeom>
+          <a:noFill/>
+          <a:ln/>
+        </p:spPr>
+        <p:txBody>
+          <a:bodyPr wrap="square" rtlCol="0" anchor="ctr"/>
+          <a:lstStyle/>
+          <a:p>
+            <a:pPr algn="l" indent="0" marL="0">
+              <a:buNone/>
+            </a:pPr>
+            <a:r>
+              <a:rPr lang="en-US" sz="1200" b="1" spc="400" kern="0" dirty="0">
+                <a:solidFill>
+                  <a:srgbClr val="EE0000"/>
+                </a:solidFill>
+                <a:latin typeface="Overpass" pitchFamily="34" charset="0"/>
+                <a:ea typeface="Overpass" pitchFamily="34" charset="-122"/>
+                <a:cs typeface="Overpass" pitchFamily="34" charset="-120"/>
+              </a:rPr>
+              <a:t>SCAN TO EXPLORE</a:t>
+            </a:r>
+            <a:endParaRPr lang="en-US" sz="1200" dirty="0"/>
+          </a:p>
+        </p:txBody>
+      </p:sp>
+      <p:sp>
+        <p:nvSpPr>
+          <p:cNvPr id="5" name="Text 2"/>
+          <p:cNvSpPr/>
+          <p:nvPr/>
+        </p:nvSpPr>
+        <p:spPr>
+          <a:xfrm>
+            <a:off x="566928" y="676656"/>
+            <a:ext cx="11055096" cy="1005840"/>
+          </a:xfrm>
+          <a:prstGeom prst="rect">
+            <a:avLst/>
+          </a:prstGeom>
+          <a:noFill/>
+          <a:ln/>
+        </p:spPr>
+        <p:txBody>
+          <a:bodyPr wrap="square" rtlCol="0" anchor="t"/>
+          <a:lstStyle/>
+          <a:p>
+            <a:pPr algn="l" indent="0" marL="0">
+              <a:buNone/>
+            </a:pPr>
+            <a:r>
+              <a:rPr lang="en-US" sz="3000" b="1" dirty="0">
+                <a:solidFill>
+                  <a:srgbClr val="151515"/>
+                </a:solidFill>
+                <a:latin typeface="Overpass" pitchFamily="34" charset="0"/>
+                <a:ea typeface="Overpass" pitchFamily="34" charset="-122"/>
+                <a:cs typeface="Overpass" pitchFamily="34" charset="-120"/>
+              </a:rPr>
+              <a:t>Take it with you</a:t>
+            </a:r>
+            <a:endParaRPr lang="en-US" sz="3000" dirty="0"/>
+          </a:p>
+        </p:txBody>
+      </p:sp>
+      <p:pic>
+        <p:nvPicPr>
+          <p:cNvPr id="6" name="Image 1" descr="./assets/qr-webassembly-site.png">    </p:cNvPr>
+          <p:cNvPicPr>
+            <a:picLocks noChangeAspect="1"/>
+          </p:cNvPicPr>
+          <p:nvPr/>
+        </p:nvPicPr>
+        <p:blipFill>
+          <a:blip r:embed="rId2"/>
+          <a:stretch>
+            <a:fillRect/>
+          </a:stretch>
+        </p:blipFill>
+        <p:spPr>
+          <a:xfrm>
+            <a:off x="2103120" y="1627632"/>
+            <a:ext cx="2834640" cy="2834640"/>
+          </a:xfrm>
+          <a:prstGeom prst="rect">
+            <a:avLst/>
+          </a:prstGeom>
+        </p:spPr>
+      </p:pic>
+      <p:sp>
+        <p:nvSpPr>
+          <p:cNvPr id="7" name="Text 3"/>
+          <p:cNvSpPr/>
+          <p:nvPr/>
+        </p:nvSpPr>
+        <p:spPr>
+          <a:xfrm>
+            <a:off x="1417320" y="4553712"/>
+            <a:ext cx="4206240" cy="365760"/>
+          </a:xfrm>
+          <a:prstGeom prst="rect">
+            <a:avLst/>
+          </a:prstGeom>
+          <a:noFill/>
+          <a:ln/>
+        </p:spPr>
+        <p:txBody>
+          <a:bodyPr wrap="square" rtlCol="0" anchor="ctr"/>
+          <a:lstStyle/>
+          <a:p>
+            <a:pPr algn="ctr" indent="0" marL="0">
+              <a:buNone/>
+            </a:pPr>
+            <a:r>
+              <a:rPr lang="en-US" sz="1800" b="1" dirty="0">
+                <a:solidFill>
+                  <a:srgbClr val="151515"/>
+                </a:solidFill>
+                <a:latin typeface="Overpass" pitchFamily="34" charset="0"/>
+                <a:ea typeface="Overpass" pitchFamily="34" charset="-122"/>
+                <a:cs typeface="Overpass" pitchFamily="34" charset="-120"/>
+              </a:rPr>
+              <a:t>The site</a:t>
+            </a:r>
+            <a:endParaRPr lang="en-US" sz="1800" dirty="0"/>
+          </a:p>
+        </p:txBody>
+      </p:sp>
+      <p:sp>
+        <p:nvSpPr>
+          <p:cNvPr id="8" name="Text 4"/>
+          <p:cNvSpPr/>
+          <p:nvPr/>
+        </p:nvSpPr>
+        <p:spPr>
+          <a:xfrm>
+            <a:off x="1325880" y="4937760"/>
+            <a:ext cx="4389120" cy="658368"/>
+          </a:xfrm>
+          <a:prstGeom prst="rect">
+            <a:avLst/>
+          </a:prstGeom>
+          <a:noFill/>
+          <a:ln/>
+        </p:spPr>
+        <p:txBody>
+          <a:bodyPr wrap="square" rtlCol="0" anchor="t"/>
+          <a:lstStyle/>
+          <a:p>
+            <a:pPr algn="ctr" indent="0" marL="0">
+              <a:buNone/>
+            </a:pPr>
+            <a:r>
+              <a:rPr lang="en-US" sz="1300" i="1" dirty="0">
+                <a:solidFill>
+                  <a:srgbClr val="5A5A5A"/>
+                </a:solidFill>
+                <a:latin typeface="Red Hat Text" pitchFamily="34" charset="0"/>
+                <a:ea typeface="Red Hat Text" pitchFamily="34" charset="-122"/>
+                <a:cs typeface="Red Hat Text" pitchFamily="34" charset="-120"/>
+              </a:rPr>
+              <a:t>Chapters, the WIT interfaces, and runnable Rust &amp; TinyGo examples</a:t>
+            </a:r>
+            <a:endParaRPr lang="en-US" sz="1300" dirty="0"/>
+          </a:p>
+        </p:txBody>
+      </p:sp>
+      <p:sp>
+        <p:nvSpPr>
+          <p:cNvPr id="9" name="Text 5"/>
+          <p:cNvSpPr/>
+          <p:nvPr/>
+        </p:nvSpPr>
+        <p:spPr>
+          <a:xfrm>
+            <a:off x="1325880" y="5596128"/>
+            <a:ext cx="4389120" cy="292608"/>
+          </a:xfrm>
+          <a:prstGeom prst="rect">
+            <a:avLst/>
+          </a:prstGeom>
+          <a:noFill/>
+          <a:ln/>
+        </p:spPr>
+        <p:txBody>
+          <a:bodyPr wrap="square" rtlCol="0" anchor="ctr"/>
+          <a:lstStyle/>
+          <a:p>
+            <a:pPr algn="ctr" indent="0" marL="0">
+              <a:buNone/>
+            </a:pPr>
+            <a:r>
+              <a:rPr lang="en-US" sz="1000" dirty="0">
+                <a:solidFill>
+                  <a:srgbClr val="EE0000"/>
+                </a:solidFill>
+                <a:latin typeface="Red Hat Mono" pitchFamily="34" charset="0"/>
+                <a:ea typeface="Red Hat Mono" pitchFamily="34" charset="-122"/>
+                <a:cs typeface="Red Hat Mono" pitchFamily="34" charset="-120"/>
+              </a:rPr>
+              <a:t>patterncatalyst.github.io/cn-patterns-and-practices-webassembly</a:t>
+            </a:r>
+            <a:endParaRPr lang="en-US" sz="1000" dirty="0"/>
+          </a:p>
+        </p:txBody>
+      </p:sp>
+      <p:pic>
+        <p:nvPicPr>
+          <p:cNvPr id="10" name="Image 2" descr="./assets/qr-hub.png">    </p:cNvPr>
+          <p:cNvPicPr>
+            <a:picLocks noChangeAspect="1"/>
+          </p:cNvPicPr>
+          <p:nvPr/>
+        </p:nvPicPr>
+        <p:blipFill>
+          <a:blip r:embed="rId3"/>
+          <a:stretch>
+            <a:fillRect/>
+          </a:stretch>
+        </p:blipFill>
+        <p:spPr>
+          <a:xfrm>
+            <a:off x="7251192" y="1627632"/>
+            <a:ext cx="2834640" cy="2834640"/>
+          </a:xfrm>
+          <a:prstGeom prst="rect">
+            <a:avLst/>
+          </a:prstGeom>
+        </p:spPr>
+      </p:pic>
+      <p:sp>
+        <p:nvSpPr>
+          <p:cNvPr id="11" name="Text 6"/>
+          <p:cNvSpPr/>
+          <p:nvPr/>
+        </p:nvSpPr>
+        <p:spPr>
+          <a:xfrm>
+            <a:off x="6565392" y="4553712"/>
+            <a:ext cx="4206240" cy="365760"/>
+          </a:xfrm>
+          <a:prstGeom prst="rect">
+            <a:avLst/>
+          </a:prstGeom>
+          <a:noFill/>
+          <a:ln/>
+        </p:spPr>
+        <p:txBody>
+          <a:bodyPr wrap="square" rtlCol="0" anchor="ctr"/>
+          <a:lstStyle/>
+          <a:p>
+            <a:pPr algn="ctr" indent="0" marL="0">
+              <a:buNone/>
+            </a:pPr>
+            <a:r>
+              <a:rPr lang="en-US" sz="1800" b="1" dirty="0">
+                <a:solidFill>
+                  <a:srgbClr val="151515"/>
+                </a:solidFill>
+                <a:latin typeface="Overpass" pitchFamily="34" charset="0"/>
+                <a:ea typeface="Overpass" pitchFamily="34" charset="-122"/>
+                <a:cs typeface="Overpass" pitchFamily="34" charset="-120"/>
+              </a:rPr>
+              <a:t>Workshops &amp; Tutorials</a:t>
+            </a:r>
+            <a:endParaRPr lang="en-US" sz="1800" dirty="0"/>
+          </a:p>
+        </p:txBody>
+      </p:sp>
+      <p:sp>
+        <p:nvSpPr>
+          <p:cNvPr id="12" name="Text 7"/>
+          <p:cNvSpPr/>
+          <p:nvPr/>
+        </p:nvSpPr>
+        <p:spPr>
+          <a:xfrm>
+            <a:off x="6473952" y="4937760"/>
+            <a:ext cx="4389120" cy="658368"/>
+          </a:xfrm>
+          <a:prstGeom prst="rect">
+            <a:avLst/>
+          </a:prstGeom>
+          <a:noFill/>
+          <a:ln/>
+        </p:spPr>
+        <p:txBody>
+          <a:bodyPr wrap="square" rtlCol="0" anchor="t"/>
+          <a:lstStyle/>
+          <a:p>
+            <a:pPr algn="ctr" indent="0" marL="0">
+              <a:buNone/>
+            </a:pPr>
+            <a:r>
+              <a:rPr lang="en-US" sz="1300" i="1" dirty="0">
+                <a:solidFill>
+                  <a:srgbClr val="5A5A5A"/>
+                </a:solidFill>
+                <a:latin typeface="Red Hat Text" pitchFamily="34" charset="0"/>
+                <a:ea typeface="Red Hat Text" pitchFamily="34" charset="-122"/>
+                <a:cs typeface="Red Hat Text" pitchFamily="34" charset="-120"/>
+              </a:rPr>
+              <a:t>The whole series: every workshop, tutorial, and deck in one place</a:t>
+            </a:r>
+            <a:endParaRPr lang="en-US" sz="1300" dirty="0"/>
+          </a:p>
+        </p:txBody>
+      </p:sp>
+      <p:sp>
+        <p:nvSpPr>
+          <p:cNvPr id="13" name="Text 8"/>
+          <p:cNvSpPr/>
+          <p:nvPr/>
+        </p:nvSpPr>
+        <p:spPr>
+          <a:xfrm>
+            <a:off x="6473952" y="5596128"/>
+            <a:ext cx="4389120" cy="292608"/>
+          </a:xfrm>
+          <a:prstGeom prst="rect">
+            <a:avLst/>
+          </a:prstGeom>
+          <a:noFill/>
+          <a:ln/>
+        </p:spPr>
+        <p:txBody>
+          <a:bodyPr wrap="square" rtlCol="0" anchor="ctr"/>
+          <a:lstStyle/>
+          <a:p>
+            <a:pPr algn="ctr" indent="0" marL="0">
+              <a:buNone/>
+            </a:pPr>
+            <a:r>
+              <a:rPr lang="en-US" sz="900" dirty="0">
+                <a:solidFill>
+                  <a:srgbClr val="EE0000"/>
+                </a:solidFill>
+                <a:latin typeface="Red Hat Mono" pitchFamily="34" charset="0"/>
+                <a:ea typeface="Red Hat Mono" pitchFamily="34" charset="-122"/>
+                <a:cs typeface="Red Hat Mono" pitchFamily="34" charset="-120"/>
+              </a:rPr>
+              <a:t>patterncatalyst.github.io/patterncatalyst-workshops-tutorials-list</a:t>
+            </a:r>
+            <a:endParaRPr lang="en-US" sz="900" dirty="0"/>
+          </a:p>
+        </p:txBody>
+      </p:sp>
+    </p:spTree>
+  </p:cSld>
+  <p:clrMapOvr>
+    <a:masterClrMapping/>
+  </p:clrMapOvr>
+</p:sld>
+</file>
+
 <file path=ppt/slides/slide5.xml><?xml version="1.0" encoding="utf-8"?>
 <p:sld xmlns:a="http://schemas.openxmlformats.org/drawingml/2006/main" xmlns:r="http://schemas.openxmlformats.org/officeDocument/2006/relationships" xmlns:p="http://schemas.openxmlformats.org/presentationml/2006/main">
   <p:cSld name="Slide 5">

</xml_diff>

<commit_message>
docs: professional-voice pass + de-reference chapter cross-refs (#27)
Chapters, READMEs, and the three companion decks:
- Rewrote ~350 narrative 'Chapter N' cross-references to name the concept
  or pattern, so each chapter reads standalone (outline TOC kept intact).
- Voice cleanup: removed hedges/filler, meta-narration, defect/issue-tracker
  framing, confessional and defensive phrasing, generated-text tells, and
  typographic emphasis. Recast em dashes. Renamed 'Gotcha' callouts to 'Note'.
- Stripped internal tracking codes (DRQ-*) from reader-facing prose.
- Decks: de-referenced chapter numbers in speaker notes and captions,
  recast em dashes in author annotations; rebuilt all three .pptx.
No code, identifiers, commands, or recorded output changed.
</commit_message>
<xml_diff>
--- a/presentation/wasm-101/wasm-101-r1.1.pptx
+++ b/presentation/wasm-101/wasm-101-r1.1.pptx
@@ -982,7 +982,7 @@
           <a:p>
             <a:r>
               <a:rPr lang="en-US" dirty="0"/>
-              <a:t>WASI isn't one interface; it's a family of them, each a self-contained WIT package covering one category of host resource: io and cli and clocks and filesystem and random form the base nearly every component needs, while http, sockets, and nn are larger surfaces each component opts into individually. A world's import list is the complete, auditable answer to what a component can reach: a reviewer doesn't need to read the Rust or Go source to know a component with no sockets import cannot open a raw TCP connection. What to show: the dashed arrows from a subset of both bands down into 'this component's world'; the point is that nothing is granted by default, not even from within the WASI family itself.</a:t>
+              <a:t>WASI is a family of interfaces, each a self-contained WIT package covering one category of host resource: io and cli and clocks and filesystem and random form the base nearly every component needs, while http, sockets, and nn are larger surfaces each component opts into individually. A world's import list is the complete, auditable answer to what a component can reach: a reviewer doesn't need to read the Rust or Go source to know a component with no sockets import cannot open a raw TCP connection. What to show: the dashed arrows from a subset of both bands down into 'this component's world'; the point is that nothing is granted by default, not even from within the WASI family itself.</a:t>
             </a:r>
             <a:endParaRPr lang="en-US" dirty="0"/>
           </a:p>
@@ -1246,7 +1246,7 @@
           <a:p>
             <a:r>
               <a:rPr lang="en-US" dirty="0"/>
-              <a:t>This section proves the Component Model's headline claim with real binaries rather than a diagram: two toolchains, two generated binding sets, one WIT source of truth, and a 2x2 composition matrix where two of the four pairings cross a language boundary and print byte-identical output. The section closes with the same claim proven across runtimes, not just across languages: one app.wasm, one sha256, under both wasmtime and a wasmCloud lattice. What to show: this section is short by design; three or four slides carry the whole proof. If time is tight, the polyglot-composition-matrix diagram alone makes the point.</a:t>
+              <a:t>This section proves the Component Model's headline claim with real binaries rather than a diagram: two toolchains, two generated binding sets, one WIT source of truth, and a 2x2 composition matrix where two of the four pairings cross a language boundary and print byte-identical output. The section closes with the same claim proven across runtimes as well as across languages: one app.wasm, one sha256, under both wasmtime and a wasmCloud lattice. What to show: this section is short by design; three or four slides carry the whole proof. If time is tight, the polyglot-composition-matrix diagram alone makes the point.</a:t>
             </a:r>
             <a:endParaRPr lang="en-US" dirty="0"/>
           </a:p>
@@ -1422,7 +1422,7 @@
           <a:p>
             <a:r>
               <a:rPr lang="en-US" dirty="0"/>
-              <a:t>Two consumers and two providers produce four possible pairings, and all four are run in this book's own verification step: Rust consumer with Rust provider, Rust consumer with Go provider, Go consumer with Rust provider, Go consumer with Go provider. All four print the identical normalized summary line character for character. The headline isn't the two same-language pairs; it's the two cross-language pairs, because wac never asks which language built either half; it only matches the WIT identifier both sides share. What to show: the two diagonal cells in the grid, rustC x goP and goC x rustP, and note that they behave exactly like the two same-language cells, which is the entire point of building the contract this way.</a:t>
+              <a:t>Two consumers and two providers produce four possible pairings, and all four are run in this book's own verification step: Rust consumer with Rust provider, Rust consumer with Go provider, Go consumer with Rust provider, Go consumer with Go provider. All four print the identical normalized summary line character for character. The two cross-language pairs are the headline, not the two same-language pairs, because wac never asks which language built either half; it only matches the WIT identifier both sides share. What to show: the two diagonal cells in the grid, rustC x goP and goC x rustP, and note that they behave exactly like the two same-language cells, which is the entire point of building the contract this way.</a:t>
             </a:r>
             <a:endParaRPr lang="en-US" dirty="0"/>
           </a:p>
@@ -1686,7 +1686,7 @@
           <a:p>
             <a:r>
               <a:rPr lang="en-US" dirty="0"/>
-              <a:t>This is the proof that closes the loop between the Component Model's boundary and the two runtime chapters this deck covers next: the identical app.wasm file, sha256 recorded once, runs under wasmtime serve as a single process and is deployed into a wasmCloud lattice through a declarative manifest, and the two sides answer the identical JSON and the identical 404 for an unknown cargo ID. The sha256 match isn't a coincidence pointed out after the fact; it's the mechanical consequence of a component's exports being defined by WIT, where a runtime's only job is to satisfy imports and call exports, never to see or change the component's own bytes. What to show: the single artifact box at the top fanning down into two bands, and the shared banner at the bottom: one build, two runtimes, no rebuild in between.</a:t>
+              <a:t>This is the proof that closes the loop between the Component Model's boundary and the two runtime substrates covered next: the identical app.wasm file, sha256 recorded once, runs under wasmtime serve as a single process and is deployed into a wasmCloud lattice through a declarative manifest, and the two sides answer the identical JSON and the identical 404 for an unknown cargo ID. The sha256 match is the mechanical consequence of a component's exports being defined by WIT, not a coincidence pointed out after the fact: a runtime's only job is to satisfy imports and call exports, never to see or change the component's own bytes. What to show: the single artifact box at the top fanning down into two bands, and the shared banner at the bottom: one build, two runtimes, no rebuild in between.</a:t>
             </a:r>
             <a:endParaRPr lang="en-US" dirty="0"/>
           </a:p>
@@ -2390,7 +2390,7 @@
           <a:p>
             <a:r>
               <a:rPr lang="en-US" dirty="0"/>
-              <a:t>A containerd shim is not a sidecar and not a webhook; it's the actual process containerd forks to run a workload, in the same lifecycle slot runc normally occupies. A RuntimeClass object gives a Pod a name to reference instead of hard-coding a containerd runtime string, and a Pod that sets runtimeClassName: wasmtime is scheduled onto the shim instead of runc, with nothing else about the Deployment, Service, or Ingress objects needing to be Wasm-specific. Installing the shim requires restarting containerd on the node, which bounces every running pod there, so it belongs before other cluster add-ons, not after. What to show: the one Pod-spec field difference between the two columns: runtimeClassName is the entire mechanism, stated as one YAML line.</a:t>
+              <a:t>A containerd shim is the actual process containerd forks to run a workload, not a sidecar or a webhook, in the same lifecycle slot runc normally occupies. A RuntimeClass object gives a Pod a name to reference instead of hard-coding a containerd runtime string, and a Pod that sets runtimeClassName: wasmtime is scheduled onto the shim instead of runc, with nothing else about the Deployment, Service, or Ingress objects needing to be Wasm-specific. Installing the shim requires restarting containerd on the node, which bounces every running pod there, so it belongs before other cluster add-ons, not after. What to show: the one Pod-spec field difference between the two columns: runtimeClassName is the entire mechanism, stated as one YAML line.</a:t>
             </a:r>
             <a:endParaRPr lang="en-US" dirty="0"/>
           </a:p>
@@ -2478,7 +2478,7 @@
           <a:p>
             <a:r>
               <a:rPr lang="en-US" dirty="0"/>
-              <a:t>This divider opens the case for server-side Wasm. The claim isn't that a component replaces a container everywhere; it's that a component wins on three specific properties (cold start, density, and the shape of its default isolation) and loses on three specific limits (heavy native dependencies, long-lived state, and a full POSIX surface). The following slides make both halves of that claim concrete before the deck reaches the Component Model. What to show: let the divider sit for a moment: it's the first of five section breaks and sets the pattern (title plus one-line claim) the audience will see four more times. If running short on time, this section can compress to the isolation-spectrum diagram and the restraint slide alone.</a:t>
+              <a:t>This divider opens the case for server-side Wasm. A component does not replace a container everywhere: it wins on three specific properties (cold start, density, and the shape of its default isolation) and loses on three specific limits (heavy native dependencies, long-lived state, and a full POSIX surface). The following slides make both halves of that claim concrete before the deck reaches the Component Model. What to show: let the divider sit for a moment: it's the first of five section breaks and sets the pattern (title plus one-line claim) the audience will see four more times. If running short on time, this section can compress to the isolation-spectrum diagram and the restraint slide alone.</a:t>
             </a:r>
             <a:endParaRPr lang="en-US" dirty="0"/>
           </a:p>
@@ -2654,7 +2654,7 @@
           <a:p>
             <a:r>
               <a:rPr lang="en-US" dirty="0"/>
-              <a:t>This closing section covers the book's three deviation chapters at a glance (Istio's mesh-layer filter, Fermyon Spin's own framework packaging, and wasi-nn's portable inference) before landing on the final project, where the two-language-one-contract claim this deck has been building stops being an assertion about one component's portability and becomes a visible property of a running system: two pods, two source languages, one answer, behind one edge. What to show: this section closes the argument; don't rush the final-project request-path diagram, since it's the slide that ties every earlier section together.</a:t>
+              <a:t>The book's three deviation chapters get a glance here (Istio's mesh-layer filter, Fermyon Spin's own framework packaging, and wasi-nn's portable inference) before landing on the final project, where the two-language-one-contract claim this deck has been building stops being an assertion about one component's portability and becomes a visible property of a running system: two pods, two source languages, one answer, behind one edge. What to show: this section closes the argument; don't rush the final-project request-path diagram, since it's the slide that ties every earlier section together.</a:t>
             </a:r>
             <a:endParaRPr lang="en-US" dirty="0"/>
           </a:p>
@@ -3094,7 +3094,7 @@
           <a:p>
             <a:r>
               <a:rPr lang="en-US" dirty="0"/>
-              <a:t>To close, bring the deck back to the one claim: a WIT contract, not a protocol and not a cloud vendor's SDK, is what makes a server-side Wasm component portable across languages, runtimes, and clusters. Capability-based security is the other half of that claim: a component's authority is exactly its resolved imports, decided once by the host, never expanded from inside the sandbox. Every runtime and every cluster this deck covered ran the identical bytes, proven by a matching sha256, not asserted by prose. For the code behind every one of these ideas, point the room at the two 201 decks. What to show: hold on the third bullet longest; 'runs unmodified everywhere' is the sentence that ties the contract-spine section to the substrates section, which is the whole arc of this deck.</a:t>
+              <a:t>To close, bring the deck back to the one claim: a WIT contract, not a protocol and not a cloud vendor's SDK, is what makes a server-side Wasm component portable across languages, runtimes, and clusters. Capability-based security is the other half of that claim: a component's authority is exactly its resolved imports, decided once by the host, never expanded from inside the sandbox. Every runtime and every cluster in this book ran the identical bytes, proven by a matching sha256, not asserted by prose. For the code behind every one of these ideas, point the room at the two 201 decks. What to show: hold on the third bullet longest; 'runs unmodified everywhere' is the sentence that ties the contract-spine section to the substrates section, which is the whole arc of this deck.</a:t>
             </a:r>
             <a:endParaRPr lang="en-US" dirty="0"/>
           </a:p>
@@ -3446,7 +3446,7 @@
           <a:p>
             <a:r>
               <a:rPr lang="en-US" dirty="0"/>
-              <a:t>The pitch rests on four properties, not a vague speed claim. Cold start and density both follow from the same mechanics: a module is already compiled, so instantiation is mostly memory allocation and import resolution, not another pass over bytecode. Isolation is the property easiest to misstate: a container is isolated by the kernel and still makes real syscalls into a kernel it shares with the host; a component has no instruction in its set that opens a file or a socket unless the host explicitly wires that capability in. Polyglot composition is unique to the Component Model rather than to Wasm generally; it's what lets this site build the same domain twice, once in Rust and once in Go, and treat the two as drop-in replacements. What to show: the four bold leads in sequence. If asked for a number, cite single-digit milliseconds for cold start and single-digit megabytes for image size; both come from the book's own Chapter 1 comparison table.</a:t>
+              <a:t>The pitch rests on four properties, not a vague speed claim. Cold start and density both follow from the same mechanics: a module is already compiled, so instantiation is mostly memory allocation and import resolution, not another pass over bytecode. Isolation is the property easiest to misstate: a container is isolated by the kernel and still makes real syscalls into a kernel it shares with the host; a component has no instruction in its set that opens a file or a socket unless the host explicitly wires that capability in. Polyglot composition is unique to the Component Model rather than to Wasm generally; it's what lets this site build the same domain twice, once in Rust and once in Go, and treat the two as drop-in replacements. What to show: the four bold leads in sequence. If asked for a number, cite single-digit milliseconds for cold start and single-digit megabytes for image size; both come from the book's own comparison table.</a:t>
             </a:r>
             <a:endParaRPr lang="en-US" dirty="0"/>
           </a:p>
@@ -3710,7 +3710,7 @@
           <a:p>
             <a:r>
               <a:rPr lang="en-US" dirty="0"/>
-              <a:t>This figure lines up three isolation mechanisms side by side: a VM isolates at the hypervisor boundary with gigabyte images and multi-second cold starts; a container isolates at the kernel boundary with namespaces and cgroups, tens-of-megabytes images, and hundreds-of-milliseconds starts; a Wasm component sandboxes at the runtime level with no ambient syscalls at all, single-digit-megabyte images, and single-digit-millisecond starts. The point isn't that smaller is always better; it's that the component's isolation mechanism is structurally different, not just faster. What to show: trace left to right across the three bands, pausing on the component band's 'deny by default' label. If the diagram doesn't render, describe the three bands verbally in the same left-to-right order (VM, container, component), each one step tighter on isolation and smaller on footprint.</a:t>
+              <a:t>This figure lines up three isolation mechanisms side by side: a VM isolates at the hypervisor boundary with gigabyte images and multi-second cold starts; a container isolates at the kernel boundary with namespaces and cgroups, tens-of-megabytes images, and hundreds-of-milliseconds starts; a Wasm component sandboxes at the runtime level with no ambient syscalls at all, single-digit-megabyte images, and single-digit-millisecond starts. The point is that the component's isolation mechanism is structurally different, beyond being faster. What to show: trace left to right across the three bands, pausing on the component band's 'deny by default' label. If the diagram doesn't render, describe the three bands verbally in the same left-to-right order (VM, container, component), each one step tighter on isolation and smaller on footprint.</a:t>
             </a:r>
             <a:endParaRPr lang="en-US" dirty="0"/>
           </a:p>
@@ -7897,7 +7897,7 @@
                 <a:ea typeface="Overpass" pitchFamily="34" charset="-122"/>
                 <a:cs typeface="Overpass" pitchFamily="34" charset="-120"/>
               </a:rPr>
-              <a:t>What this deck covers</a:t>
+              <a:t>Five Acts, One Appendix</a:t>
             </a:r>
             <a:endParaRPr lang="en-US" sz="3000" dirty="0"/>
           </a:p>

</xml_diff>